<commit_message>
fix: update polish terminology for less artifical feel
</commit_message>
<xml_diff>
--- a/psw/pitch_slides/feedback-pitch.pptx
+++ b/psw/pitch_slides/feedback-pitch.pptx
@@ -200,7 +200,7 @@
           <a:p>
             <a:r>
               <a:rPr lang="pl-PL"/>
-              <a:t>[1:10–1:55] Oto schemat jednej interakcji, a nie gotowy projekt poziomu. Po lewej przeciwnik wysyła pocisk w stronę gracza. W środku gracz paruje i odwraca jego kierunek. Po prawej odbity pocisk trafia przełącznik, który otwiera drzwi. Przełącznik reaguje na pocisk po odbiciu. Pozostaje przejść dalej. Ten przykład pokazuje połączenie obserwacji, timingu i zagadki.</a:t>
+              <a:t>[1:10–1:55] Oto schemat jednej interakcji, a nie gotowy projekt poziomu. Po lewej przeciwnik wysyła pocisk w stronę gracza. W środku gracz paruje i odwraca jego kierunek. Po prawej odbity pocisk trafia przełącznik, który otwiera drzwi. Przełącznik reaguje na pocisk po odbiciu. Pozostaje przejść dalej. Ten przykład pokazuje połączenie obserwacji, wyczucia czasu i rozwiązywania zagadek.</a:t>
             </a:r>
           </a:p>
           <a:p>
@@ -314,7 +314,7 @@
           <a:p>
             <a:r>
               <a:rPr lang="pl-PL"/>
-              <a:t>[2:30–3:05] Chcemy, żeby każdy poziom zaczynał się od zrozumienia sytuacji, a kończył płynnym wykonaniem. Pomyłka prowadzi do szybkiej kolejnej próby. Postęp wynika z poznania zasad, rozpoznawania ataków i doskonalenia własnego timingu. Nie pokazujemy tu obiecanego czasu przejścia ani wyników playtestów.</a:t>
+              <a:t>[2:30–3:05] Chcemy, żeby każdy poziom zaczynał się od zrozumienia sytuacji, a kończył płynnym wykonaniem. Pomyłka prowadzi do szybkiej kolejnej próby. Postęp wynika z poznania zasad, rozpoznawania ataków i coraz lepszego wyczucia momentu parowania. Nie pokazujemy tu obiecanego czasu przejścia ani wyników testów z graczami.</a:t>
             </a:r>
           </a:p>
           <a:p>
@@ -416,7 +416,7 @@
           <a:p>
             <a:r>
               <a:rPr lang="pl-PL"/>
-              <a:t>[3:40–4:10] To jest istniejący mockup menu oraz oryginalna postać z dostarczonego pliku Figma Make. Po prawej widzimy neutralną pozę oraz klatkę animacji parowania mieczem. To statyczne kadry odzyskanych komponentów SVG, nie przerysowane postacie. Traktujemy go jako kierunek do dalszej rozmowy, nie jako zatwierdzoną oprawę całej gry. Etykieta wersji w obrazie należy do makiety i nie oznacza wydanej wersji gry.</a:t>
+              <a:t>[3:40–4:10] To jest wstępna makieta menu oraz oryginalna postać z dostarczonego pliku Figma Make. Po prawej widzimy neutralną pozę oraz klatkę animacji parowania mieczem. To statyczne kadry odzyskanych komponentów SVG, nie przerysowane postacie. Traktujemy te materiały jako punkt wyjścia do dalszej rozmowy, nie jako zatwierdzoną oprawę całej gry. Etykieta wersji w obrazie należy do makiety i nie oznacza wydanej wersji gry.</a:t>
             </a:r>
           </a:p>
           <a:p>
@@ -690,7 +690,7 @@
                 <a:ea typeface="Lato"/>
                 <a:cs typeface="Lato"/>
               </a:rPr>
-              <a:t>PITCH PROJEKTU</a:t>
+              <a:t>KONCEPCJA GRY</a:t>
             </a:r>
             <a:endParaRPr lang="pl-PL" sz="1140"/>
           </a:p>
@@ -963,7 +963,7 @@
                 <a:ea typeface="Lato"/>
                 <a:cs typeface="Lato"/>
               </a:rPr>
-              <a:t>Siła przeciwnika.</a:t>
+              <a:t>Wykorzystaj siłę</a:t>
             </a:r>
             <a:endParaRPr lang="pl-PL" sz="3960"/>
           </a:p>
@@ -985,7 +985,7 @@
                 <a:ea typeface="Lato"/>
                 <a:cs typeface="Lato"/>
               </a:rPr>
-              <a:t>Twój następny ruch.</a:t>
+              <a:t>przeciwnika.</a:t>
             </a:r>
             <a:endParaRPr lang="pl-PL" sz="3960"/>
           </a:p>
@@ -1031,7 +1031,7 @@
                 <a:ea typeface="Lato"/>
                 <a:cs typeface="Lato"/>
               </a:rPr>
-              <a:t>Parowanie, które pozwala</a:t>
+              <a:t>Paruj ataki, pokonuj przeszkody</a:t>
             </a:r>
             <a:endParaRPr lang="pl-PL" sz="1800"/>
           </a:p>
@@ -1053,7 +1053,7 @@
                 <a:ea typeface="Lato"/>
                 <a:cs typeface="Lato"/>
               </a:rPr>
-              <a:t>przetrwać, poruszać się i odkrywać drogę.</a:t>
+              <a:t>i rozwiązuj zagadki.</a:t>
             </a:r>
             <a:endParaRPr lang="pl-PL" sz="1800"/>
           </a:p>
@@ -1934,7 +1934,7 @@
                 <a:ea typeface="Lato"/>
                 <a:cs typeface="Lato"/>
               </a:rPr>
-              <a:t>01 / OBIETNICA GRY</a:t>
+              <a:t>01 / GŁÓWNA MECHANIKA</a:t>
             </a:r>
             <a:endParaRPr lang="pl-PL" sz="1140"/>
           </a:p>
@@ -2299,7 +2299,7 @@
                 <a:ea typeface="Lato"/>
                 <a:cs typeface="Lato"/>
               </a:rPr>
-              <a:t>Wykorzystaj atak przeciwnika.</a:t>
+              <a:t>Skieruj go na przeciwnika.</a:t>
             </a:r>
             <a:endParaRPr lang="pl-PL" sz="1500"/>
           </a:p>
@@ -2619,7 +2619,7 @@
                 <a:ea typeface="Lato"/>
                 <a:cs typeface="Lato"/>
               </a:rPr>
-              <a:t>Uruchom element otoczenia.</a:t>
+              <a:t>Uruchom przełącznik.</a:t>
             </a:r>
             <a:endParaRPr lang="pl-PL" sz="1500"/>
           </a:p>
@@ -3063,7 +3063,7 @@
 
 <file path=ppt/slides/slide3.xml><?xml version="1.0" encoding="utf-8"?>
 <p:sld xmlns:a="http://schemas.openxmlformats.org/drawingml/2006/main" xmlns:p="http://schemas.openxmlformats.org/presentationml/2006/main" xmlns:r="http://schemas.openxmlformats.org/officeDocument/2006/relationships">
-  <p:cSld name="Zagrożenie staje się rozwiązaniem.">
+  <p:cSld name="Odbij pocisk. Otwórz przejście.">
     <p:spTree>
       <p:nvGrpSpPr>
         <p:cNvPr id="1" name=""/>
@@ -3186,7 +3186,7 @@
                 <a:ea typeface="Lato"/>
                 <a:cs typeface="Lato"/>
               </a:rPr>
-              <a:t>Zagrożenie staje się rozwiązaniem.</a:t>
+              <a:t>Odbij pocisk. Otwórz przejście.</a:t>
             </a:r>
             <a:endParaRPr lang="pl-PL" sz="3720"/>
           </a:p>
@@ -3299,7 +3299,7 @@
                 <a:ea typeface="Lato"/>
                 <a:cs typeface="Lato"/>
               </a:rPr>
-              <a:t>Storyboard koncepcyjny</a:t>
+              <a:t>Schemat interakcji</a:t>
             </a:r>
             <a:endParaRPr lang="pl-PL" sz="1020"/>
           </a:p>
@@ -3413,7 +3413,7 @@
                 <a:ea typeface="Lato"/>
                 <a:cs typeface="Lato"/>
               </a:rPr>
-              <a:t>1  Sprowokuj</a:t>
+              <a:t>1  Wyczekaj</a:t>
             </a:r>
             <a:endParaRPr lang="pl-PL" sz="1740"/>
           </a:p>
@@ -3861,7 +3861,7 @@
                 <a:ea typeface="Lato"/>
                 <a:cs typeface="Lato"/>
               </a:rPr>
-              <a:t>Obserwujesz atak</a:t>
+              <a:t>Obserwuj atak.</a:t>
             </a:r>
             <a:endParaRPr lang="pl-PL" sz="1740"/>
           </a:p>
@@ -3883,7 +3883,7 @@
                 <a:ea typeface="Lato"/>
                 <a:cs typeface="Lato"/>
               </a:rPr>
-              <a:t>i wybierasz moment.</a:t>
+              <a:t>Wybierz moment.</a:t>
             </a:r>
             <a:endParaRPr lang="pl-PL" sz="1740"/>
           </a:p>
@@ -4399,7 +4399,7 @@
                 <a:ea typeface="Lato"/>
                 <a:cs typeface="Lato"/>
               </a:rPr>
-              <a:t>Odbijasz pocisk</a:t>
+              <a:t>Odbij pocisk</a:t>
             </a:r>
             <a:endParaRPr lang="pl-PL" sz="1740"/>
           </a:p>
@@ -4999,7 +4999,7 @@
                 <a:ea typeface="Lato"/>
                 <a:cs typeface="Lato"/>
               </a:rPr>
-              <a:t>Możesz ruszyć dalej.</a:t>
+              <a:t>Ruszaj dalej.</a:t>
             </a:r>
             <a:endParaRPr lang="pl-PL" sz="1740"/>
           </a:p>
@@ -5015,7 +5015,7 @@
 
 <file path=ppt/slides/slide4.xml><?xml version="1.0" encoding="utf-8"?>
 <p:sld xmlns:a="http://schemas.openxmlformats.org/drawingml/2006/main" xmlns:p="http://schemas.openxmlformats.org/presentationml/2006/main" xmlns:r="http://schemas.openxmlformats.org/officeDocument/2006/relationships">
-  <p:cSld name="Sparuj. Wykorzystaj pęd.">
+  <p:cSld name="Przejmij pęd. Dotrzyj dalej.">
     <p:spTree>
       <p:nvGrpSpPr>
         <p:cNvPr id="1" name=""/>
@@ -5138,7 +5138,7 @@
                 <a:ea typeface="Lato"/>
                 <a:cs typeface="Lato"/>
               </a:rPr>
-              <a:t>Sparuj. Wykorzystaj pęd.</a:t>
+              <a:t>Przejmij pęd. Dotrzyj dalej.</a:t>
             </a:r>
             <a:endParaRPr lang="pl-PL" sz="3720"/>
           </a:p>
@@ -6111,7 +6111,7 @@
                 <a:ea typeface="Lato"/>
                 <a:cs typeface="Lato"/>
               </a:rPr>
-              <a:t>Atak → parowanie → zmiana ruchu</a:t>
+              <a:t>Atak → parowanie → pęd</a:t>
             </a:r>
             <a:endParaRPr lang="pl-PL" sz="1620"/>
           </a:p>
@@ -6157,7 +6157,7 @@
                 <a:ea typeface="Lato"/>
                 <a:cs typeface="Lato"/>
               </a:rPr>
-              <a:t>Twoja obrona</a:t>
+              <a:t>Paruj, by dotrzeć</a:t>
             </a:r>
             <a:endParaRPr lang="pl-PL" sz="2460"/>
           </a:p>
@@ -6179,7 +6179,7 @@
                 <a:ea typeface="Lato"/>
                 <a:cs typeface="Lato"/>
               </a:rPr>
-              <a:t>wyznacza trasę.</a:t>
+              <a:t>na platformę.</a:t>
             </a:r>
             <a:endParaRPr lang="pl-PL" sz="2460"/>
           </a:p>
@@ -6269,7 +6269,7 @@
                 <a:ea typeface="Lato"/>
                 <a:cs typeface="Lato"/>
               </a:rPr>
-              <a:t>Inna droga przez poziom.</a:t>
+              <a:t>Kolejna droga do celu.</a:t>
             </a:r>
             <a:endParaRPr lang="pl-PL" sz="1740"/>
           </a:p>
@@ -6285,7 +6285,7 @@
 
 <file path=ppt/slides/slide5.xml><?xml version="1.0" encoding="utf-8"?>
 <p:sld xmlns:a="http://schemas.openxmlformats.org/drawingml/2006/main" xmlns:p="http://schemas.openxmlformats.org/presentationml/2006/main" xmlns:r="http://schemas.openxmlformats.org/officeDocument/2006/relationships">
-  <p:cSld name="Zobacz. Zaplanuj. Wykonaj.">
+  <p:cSld name="Obserwuj. Zaplanuj. Działaj.">
     <p:spTree>
       <p:nvGrpSpPr>
         <p:cNvPr id="1" name=""/>
@@ -6408,7 +6408,7 @@
                 <a:ea typeface="Lato"/>
                 <a:cs typeface="Lato"/>
               </a:rPr>
-              <a:t>Zobacz. Zaplanuj. Wykonaj.</a:t>
+              <a:t>Obserwuj. Zaplanuj. Działaj.</a:t>
             </a:r>
             <a:endParaRPr lang="pl-PL" sz="3720"/>
           </a:p>
@@ -6727,7 +6727,7 @@
                 <a:ea typeface="Lato"/>
                 <a:cs typeface="Lato"/>
               </a:rPr>
-              <a:t>Rozpoznajesz atak</a:t>
+              <a:t>Rozpoznaj atak.</a:t>
             </a:r>
             <a:endParaRPr lang="pl-PL" sz="1740"/>
           </a:p>
@@ -6749,7 +6749,7 @@
                 <a:ea typeface="Lato"/>
                 <a:cs typeface="Lato"/>
               </a:rPr>
-              <a:t>i układ przeszkód.</a:t>
+              <a:t>Sprawdź układ przeszkód.</a:t>
             </a:r>
             <a:endParaRPr lang="pl-PL" sz="1740"/>
           </a:p>
@@ -6909,7 +6909,7 @@
                 <a:ea typeface="Lato"/>
                 <a:cs typeface="Lato"/>
               </a:rPr>
-              <a:t>Wybierasz moment</a:t>
+              <a:t>Zaplanuj, kiedy</a:t>
             </a:r>
             <a:endParaRPr lang="pl-PL" sz="1740"/>
           </a:p>
@@ -6931,7 +6931,7 @@
                 <a:ea typeface="Lato"/>
                 <a:cs typeface="Lato"/>
               </a:rPr>
-              <a:t>i sposób użycia parry.</a:t>
+              <a:t>i jak sparować atak.</a:t>
             </a:r>
             <a:endParaRPr lang="pl-PL" sz="1740"/>
           </a:p>
@@ -7091,7 +7091,7 @@
                 <a:ea typeface="Lato"/>
                 <a:cs typeface="Lato"/>
               </a:rPr>
-              <a:t>Łączysz refleks</a:t>
+              <a:t>Sparuj atak.</a:t>
             </a:r>
             <a:endParaRPr lang="pl-PL" sz="1740"/>
           </a:p>
@@ -7113,7 +7113,7 @@
                 <a:ea typeface="Lato"/>
                 <a:cs typeface="Lato"/>
               </a:rPr>
-              <a:t>z rozwiązaniem zagadki.</a:t>
+              <a:t>Rozwiąż zagadkę.</a:t>
             </a:r>
             <a:endParaRPr lang="pl-PL" sz="1740"/>
           </a:p>
@@ -7246,7 +7246,7 @@
                 <a:ea typeface="Lato"/>
                 <a:cs typeface="Lato"/>
               </a:rPr>
-              <a:t>Pomyłka → szybka kolejna próba</a:t>
+              <a:t>Pomyłka → szybki powrót do gry</a:t>
             </a:r>
             <a:endParaRPr lang="pl-PL" sz="1680"/>
           </a:p>
@@ -7262,7 +7262,7 @@
 
 <file path=ppt/slides/slide6.xml><?xml version="1.0" encoding="utf-8"?>
 <p:sld xmlns:a="http://schemas.openxmlformats.org/drawingml/2006/main" xmlns:p="http://schemas.openxmlformats.org/presentationml/2006/main" xmlns:r="http://schemas.openxmlformats.org/officeDocument/2006/relationships">
-  <p:cSld name="Refleks spotyka łamigłówkę.">
+  <p:cSld name="Dla miłośników zręczności i zagadek.">
     <p:spTree>
       <p:nvGrpSpPr>
         <p:cNvPr id="1" name=""/>
@@ -7385,7 +7385,7 @@
                 <a:ea typeface="Lato"/>
                 <a:cs typeface="Lato"/>
               </a:rPr>
-              <a:t>Refleks spotyka łamigłówkę.</a:t>
+              <a:t>Dla miłośników zręczności i zagadek.</a:t>
             </a:r>
             <a:endParaRPr lang="pl-PL" sz="3720"/>
           </a:p>
@@ -8090,7 +8090,7 @@
                 <a:ea typeface="Lato"/>
                 <a:cs typeface="Lato"/>
               </a:rPr>
-              <a:t>Coraz płynniejsze przejścia</a:t>
+              <a:t>Płynne pokonywanie poziomów</a:t>
             </a:r>
             <a:endParaRPr lang="pl-PL" sz="2100"/>
           </a:p>
@@ -8106,7 +8106,7 @@
 
 <file path=ppt/slides/slide7.xml><?xml version="1.0" encoding="utf-8"?>
 <p:sld xmlns:a="http://schemas.openxmlformats.org/drawingml/2006/main" xmlns:p="http://schemas.openxmlformats.org/presentationml/2006/main" xmlns:r="http://schemas.openxmlformats.org/officeDocument/2006/relationships">
-  <p:cSld name="Pierwszy obraz świata Feedback.">
+  <p:cSld name="Tak może wyglądać Feedback.">
     <p:spTree>
       <p:nvGrpSpPr>
         <p:cNvPr id="1" name=""/>
@@ -8183,7 +8183,7 @@
                 <a:ea typeface="Lato"/>
                 <a:cs typeface="Lato"/>
               </a:rPr>
-              <a:t>06 / PIERWSZY KIERUNEK WIZUALNY</a:t>
+              <a:t>06 / KONCEPCJA GRAFICZNA</a:t>
             </a:r>
             <a:endParaRPr lang="pl-PL" sz="1140"/>
           </a:p>
@@ -8296,7 +8296,7 @@
                 <a:ea typeface="Lato"/>
                 <a:cs typeface="Lato"/>
               </a:rPr>
-              <a:t>Oryginalny mockup • Figma Make</a:t>
+              <a:t>Makieta • Figma Make</a:t>
             </a:r>
             <a:endParaRPr lang="pl-PL" sz="1020"/>
           </a:p>
@@ -8460,7 +8460,7 @@
                 <a:ea typeface="Lato"/>
                 <a:cs typeface="Lato"/>
               </a:rPr>
-              <a:t>ISTNIEJĄCY MOCKUP</a:t>
+              <a:t>WSTĘPNA MAKIETA</a:t>
             </a:r>
             <a:endParaRPr lang="pl-PL" sz="1080"/>
           </a:p>
@@ -8506,7 +8506,7 @@
                 <a:ea typeface="Lato"/>
                 <a:cs typeface="Lato"/>
               </a:rPr>
-              <a:t>Pierwszy obraz</a:t>
+              <a:t>Tak może wyglądać</a:t>
             </a:r>
             <a:endParaRPr lang="pl-PL" sz="3540"/>
           </a:p>
@@ -8528,7 +8528,7 @@
                 <a:ea typeface="Lato"/>
                 <a:cs typeface="Lato"/>
               </a:rPr>
-              <a:t>świata Feedback.</a:t>
+              <a:t>Feedback.</a:t>
             </a:r>
             <a:endParaRPr lang="pl-PL" sz="3540"/>
           </a:p>
@@ -8714,7 +8714,7 @@
                 <a:ea typeface="Lato"/>
                 <a:cs typeface="Lato"/>
               </a:rPr>
-              <a:t>Postać i menu z istniejącej makiety</a:t>
+              <a:t>Menu i postać z makiety gry</a:t>
             </a:r>
             <a:endParaRPr lang="pl-PL" sz="1320"/>
           </a:p>
@@ -8966,7 +8966,7 @@
                 <a:ea typeface="Lato"/>
                 <a:cs typeface="Lato"/>
               </a:rPr>
-              <a:t>Zakres zapisany w specyfikacji • plan</a:t>
+              <a:t>Planowany zakres prototypu</a:t>
             </a:r>
             <a:endParaRPr lang="pl-PL" sz="1020"/>
           </a:p>
@@ -9332,7 +9332,7 @@
                 <a:ea typeface="Lato"/>
                 <a:cs typeface="Lato"/>
               </a:rPr>
-              <a:t>Atak dystansowy i fizyczny</a:t>
+              <a:t>Ataki na dystans i w zwarciu</a:t>
             </a:r>
             <a:endParaRPr lang="pl-PL" sz="1500"/>
           </a:p>
@@ -9904,7 +9904,7 @@
                 <a:ea typeface="Lato"/>
                 <a:cs typeface="Lato"/>
               </a:rPr>
-              <a:t>Pytania i uwagi do koncepcji</a:t>
+              <a:t>Porozmawiajmy o grze</a:t>
             </a:r>
             <a:endParaRPr lang="pl-PL" sz="1920"/>
           </a:p>

</xml_diff>